<commit_message>
Make every story map card readable without opening it
Sixteen card titles were shorthand that only made sense once you had
opened the ticket, and several then read as a different thing from the
ticket they opened. "Confirm recognition" is US-012, confirm a driver
avoided harm. "Risk, neutral or credit" is ADR-0010, what kind of event
it was. "Watch the clip, either side" is US-005, before and after.

Each card now says what it is in the words its ticket uses, so the card
and the page it opens sound like the same thing.

Also fixes a wrong link. "Headway and fatigue" pointed at ADR-0012,
which is about attaching every signal. The decision that keeps headway
out of v1 and rejects fatigue on reliability is ADR-0001. That was also
the duplicate ID a reviewer spotted on the slide: 24 cards now point at
24 distinct records.

Co-Authored-By: Claude Opus 5 <noreply@anthropic.com>
Claude-Session: https://claude.ai/code/session_018sKrcprqkNQmfDKnYFUhGV
</commit_message>
<xml_diff>
--- a/deck/cameramatics-danny-daley.pptx
+++ b/deck/cameramatics-danny-daley.pptx
@@ -13518,7 +13518,7 @@
                 <a:ea typeface="Calibri" pitchFamily="34" charset="-122"/>
                 <a:cs typeface="Calibri" pitchFamily="34" charset="-120"/>
               </a:rPr>
-              <a:t>Interrupt. The email goes out carrying almost nothing. The clip is pushed where the device flagged the event high and fetched where it did not, so the screen says which of those is happening rather than implying footage is already there.</a:t>
+              <a:t>Interrupt. An email goes out carrying almost nothing, and the clip is fetched straight away if the device has not already sent it.</a:t>
             </a:r>
             <a:endParaRPr lang="en-US" sz="1300" dirty="0"/>
           </a:p>
@@ -15553,7 +15553,7 @@
                 <a:latin typeface="Calibri" pitchFamily="34" charset="0"/>
                 <a:ea typeface="Calibri" pitchFamily="34" charset="-122"/>
                 <a:cs typeface="Calibri" pitchFamily="34" charset="-120"/>
-                <a:hlinkClick r:id="rId2" invalidUrl="" action="" tgtFrame="" tooltip="Four triggers, every signal" history="1" highlightClick="0" endSnd="0">
+                <a:hlinkClick r:id="rId2" invalidUrl="" action="" tgtFrame="" tooltip="Every event carries every signal" history="1" highlightClick="0" endSnd="0">
                   <a:extLst>
                     <a:ext uri="{A12FA001-AC4F-418D-AE19-62706E023703}">
                       <ahyp:hlinkClr xmlns:ahyp="http://schemas.microsoft.com/office/drawing/2018/hyperlinkcolor" val="tx"/>
@@ -15581,7 +15581,7 @@
                 <a:latin typeface="Calibri" pitchFamily="34" charset="0"/>
                 <a:ea typeface="Calibri" pitchFamily="34" charset="-122"/>
                 <a:cs typeface="Calibri" pitchFamily="34" charset="-120"/>
-                <a:hlinkClick r:id="rId3" invalidUrl="" action="" tgtFrame="" tooltip="Four triggers, every signal" history="1" highlightClick="0" endSnd="0">
+                <a:hlinkClick r:id="rId3" invalidUrl="" action="" tgtFrame="" tooltip="Every event carries every signal" history="1" highlightClick="0" endSnd="0">
                   <a:extLst>
                     <a:ext uri="{A12FA001-AC4F-418D-AE19-62706E023703}">
                       <ahyp:hlinkClr xmlns:ahyp="http://schemas.microsoft.com/office/drawing/2018/hyperlinkcolor" val="tx"/>
@@ -15589,7 +15589,7 @@
                   </a:extLst>
                 </a:hlinkClick>
               </a:rPr>
-              <a:t>Four triggers, every signal</a:t>
+              <a:t>Every event carries every signal</a:t>
             </a:r>
             <a:endParaRPr lang="en-US" sz="660" dirty="0"/>
           </a:p>
@@ -15807,7 +15807,7 @@
                 <a:latin typeface="Calibri" pitchFamily="34" charset="0"/>
                 <a:ea typeface="Calibri" pitchFamily="34" charset="-122"/>
                 <a:cs typeface="Calibri" pitchFamily="34" charset="-120"/>
-                <a:hlinkClick r:id="rId6" invalidUrl="" action="" tgtFrame="" tooltip="Four bands, each with an action" history="1" highlightClick="0" endSnd="0">
+                <a:hlinkClick r:id="rId6" invalidUrl="" action="" tgtFrame="" tooltip="Severity decides the action" history="1" highlightClick="0" endSnd="0">
                   <a:extLst>
                     <a:ext uri="{A12FA001-AC4F-418D-AE19-62706E023703}">
                       <ahyp:hlinkClr xmlns:ahyp="http://schemas.microsoft.com/office/drawing/2018/hyperlinkcolor" val="tx"/>
@@ -15835,7 +15835,7 @@
                 <a:latin typeface="Calibri" pitchFamily="34" charset="0"/>
                 <a:ea typeface="Calibri" pitchFamily="34" charset="-122"/>
                 <a:cs typeface="Calibri" pitchFamily="34" charset="-120"/>
-                <a:hlinkClick r:id="rId7" invalidUrl="" action="" tgtFrame="" tooltip="Four bands, each with an action" history="1" highlightClick="0" endSnd="0">
+                <a:hlinkClick r:id="rId7" invalidUrl="" action="" tgtFrame="" tooltip="Severity decides the action" history="1" highlightClick="0" endSnd="0">
                   <a:extLst>
                     <a:ext uri="{A12FA001-AC4F-418D-AE19-62706E023703}">
                       <ahyp:hlinkClr xmlns:ahyp="http://schemas.microsoft.com/office/drawing/2018/hyperlinkcolor" val="tx"/>
@@ -15843,7 +15843,7 @@
                   </a:extLst>
                 </a:hlinkClick>
               </a:rPr>
-              <a:t>Four bands, each with an action</a:t>
+              <a:t>Severity decides the action</a:t>
             </a:r>
             <a:endParaRPr lang="en-US" sz="660" dirty="0"/>
           </a:p>
@@ -15934,7 +15934,7 @@
                 <a:latin typeface="Calibri" pitchFamily="34" charset="0"/>
                 <a:ea typeface="Calibri" pitchFamily="34" charset="-122"/>
                 <a:cs typeface="Calibri" pitchFamily="34" charset="-120"/>
-                <a:hlinkClick r:id="rId8" invalidUrl="" action="" tgtFrame="" tooltip="Risk, neutral or credit" history="1" highlightClick="0" endSnd="0">
+                <a:hlinkClick r:id="rId8" invalidUrl="" action="" tgtFrame="" tooltip="What kind of event it was" history="1" highlightClick="0" endSnd="0">
                   <a:extLst>
                     <a:ext uri="{A12FA001-AC4F-418D-AE19-62706E023703}">
                       <ahyp:hlinkClr xmlns:ahyp="http://schemas.microsoft.com/office/drawing/2018/hyperlinkcolor" val="tx"/>
@@ -15962,7 +15962,7 @@
                 <a:latin typeface="Calibri" pitchFamily="34" charset="0"/>
                 <a:ea typeface="Calibri" pitchFamily="34" charset="-122"/>
                 <a:cs typeface="Calibri" pitchFamily="34" charset="-120"/>
-                <a:hlinkClick r:id="rId9" invalidUrl="" action="" tgtFrame="" tooltip="Risk, neutral or credit" history="1" highlightClick="0" endSnd="0">
+                <a:hlinkClick r:id="rId9" invalidUrl="" action="" tgtFrame="" tooltip="What kind of event it was" history="1" highlightClick="0" endSnd="0">
                   <a:extLst>
                     <a:ext uri="{A12FA001-AC4F-418D-AE19-62706E023703}">
                       <ahyp:hlinkClr xmlns:ahyp="http://schemas.microsoft.com/office/drawing/2018/hyperlinkcolor" val="tx"/>
@@ -15970,7 +15970,7 @@
                   </a:extLst>
                 </a:hlinkClick>
               </a:rPr>
-              <a:t>Risk, neutral or credit</a:t>
+              <a:t>What kind of event it was</a:t>
             </a:r>
             <a:endParaRPr lang="en-US" sz="660" dirty="0"/>
           </a:p>
@@ -16315,7 +16315,7 @@
                 <a:latin typeface="Calibri" pitchFamily="34" charset="0"/>
                 <a:ea typeface="Calibri" pitchFamily="34" charset="-122"/>
                 <a:cs typeface="Calibri" pitchFamily="34" charset="-120"/>
-                <a:hlinkClick r:id="rId14" invalidUrl="" action="" tgtFrame="" tooltip="The set closes, visibly" history="1" highlightClick="0" endSnd="0">
+                <a:hlinkClick r:id="rId14" invalidUrl="" action="" tgtFrame="" tooltip="The set closes, nothing vanishes" history="1" highlightClick="0" endSnd="0">
                   <a:extLst>
                     <a:ext uri="{A12FA001-AC4F-418D-AE19-62706E023703}">
                       <ahyp:hlinkClr xmlns:ahyp="http://schemas.microsoft.com/office/drawing/2018/hyperlinkcolor" val="tx"/>
@@ -16343,7 +16343,7 @@
                 <a:latin typeface="Calibri" pitchFamily="34" charset="0"/>
                 <a:ea typeface="Calibri" pitchFamily="34" charset="-122"/>
                 <a:cs typeface="Calibri" pitchFamily="34" charset="-120"/>
-                <a:hlinkClick r:id="rId15" invalidUrl="" action="" tgtFrame="" tooltip="The set closes, visibly" history="1" highlightClick="0" endSnd="0">
+                <a:hlinkClick r:id="rId15" invalidUrl="" action="" tgtFrame="" tooltip="The set closes, nothing vanishes" history="1" highlightClick="0" endSnd="0">
                   <a:extLst>
                     <a:ext uri="{A12FA001-AC4F-418D-AE19-62706E023703}">
                       <ahyp:hlinkClr xmlns:ahyp="http://schemas.microsoft.com/office/drawing/2018/hyperlinkcolor" val="tx"/>
@@ -16351,7 +16351,7 @@
                   </a:extLst>
                 </a:hlinkClick>
               </a:rPr>
-              <a:t>The set closes, visibly</a:t>
+              <a:t>The set closes, nothing vanishes</a:t>
             </a:r>
             <a:endParaRPr lang="en-US" sz="660" dirty="0"/>
           </a:p>
@@ -16569,7 +16569,7 @@
                 <a:latin typeface="Calibri" pitchFamily="34" charset="0"/>
                 <a:ea typeface="Calibri" pitchFamily="34" charset="-122"/>
                 <a:cs typeface="Calibri" pitchFamily="34" charset="-120"/>
-                <a:hlinkClick r:id="rId18" invalidUrl="" action="" tgtFrame="" tooltip="Dismiss one, with a reason" history="1" highlightClick="0" endSnd="0">
+                <a:hlinkClick r:id="rId18" invalidUrl="" action="" tgtFrame="" tooltip="Dismiss a single event, with a reason" history="1" highlightClick="0" endSnd="0">
                   <a:extLst>
                     <a:ext uri="{A12FA001-AC4F-418D-AE19-62706E023703}">
                       <ahyp:hlinkClr xmlns:ahyp="http://schemas.microsoft.com/office/drawing/2018/hyperlinkcolor" val="tx"/>
@@ -16597,7 +16597,7 @@
                 <a:latin typeface="Calibri" pitchFamily="34" charset="0"/>
                 <a:ea typeface="Calibri" pitchFamily="34" charset="-122"/>
                 <a:cs typeface="Calibri" pitchFamily="34" charset="-120"/>
-                <a:hlinkClick r:id="rId19" invalidUrl="" action="" tgtFrame="" tooltip="Dismiss one, with a reason" history="1" highlightClick="0" endSnd="0">
+                <a:hlinkClick r:id="rId19" invalidUrl="" action="" tgtFrame="" tooltip="Dismiss a single event, with a reason" history="1" highlightClick="0" endSnd="0">
                   <a:extLst>
                     <a:ext uri="{A12FA001-AC4F-418D-AE19-62706E023703}">
                       <ahyp:hlinkClr xmlns:ahyp="http://schemas.microsoft.com/office/drawing/2018/hyperlinkcolor" val="tx"/>
@@ -16605,7 +16605,7 @@
                   </a:extLst>
                 </a:hlinkClick>
               </a:rPr>
-              <a:t>Dismiss one, with a reason</a:t>
+              <a:t>Dismiss a single event, with a reason</a:t>
             </a:r>
             <a:endParaRPr lang="en-US" sz="660" dirty="0"/>
           </a:p>
@@ -16696,7 +16696,7 @@
                 <a:latin typeface="Calibri" pitchFamily="34" charset="0"/>
                 <a:ea typeface="Calibri" pitchFamily="34" charset="-122"/>
                 <a:cs typeface="Calibri" pitchFamily="34" charset="-120"/>
-                <a:hlinkClick r:id="rId20" invalidUrl="" action="" tgtFrame="" tooltip="Watch the clip, either side" history="1" highlightClick="0" endSnd="0">
+                <a:hlinkClick r:id="rId20" invalidUrl="" action="" tgtFrame="" tooltip="Watch the clip, before and after" history="1" highlightClick="0" endSnd="0">
                   <a:extLst>
                     <a:ext uri="{A12FA001-AC4F-418D-AE19-62706E023703}">
                       <ahyp:hlinkClr xmlns:ahyp="http://schemas.microsoft.com/office/drawing/2018/hyperlinkcolor" val="tx"/>
@@ -16724,7 +16724,7 @@
                 <a:latin typeface="Calibri" pitchFamily="34" charset="0"/>
                 <a:ea typeface="Calibri" pitchFamily="34" charset="-122"/>
                 <a:cs typeface="Calibri" pitchFamily="34" charset="-120"/>
-                <a:hlinkClick r:id="rId21" invalidUrl="" action="" tgtFrame="" tooltip="Watch the clip, either side" history="1" highlightClick="0" endSnd="0">
+                <a:hlinkClick r:id="rId21" invalidUrl="" action="" tgtFrame="" tooltip="Watch the clip, before and after" history="1" highlightClick="0" endSnd="0">
                   <a:extLst>
                     <a:ext uri="{A12FA001-AC4F-418D-AE19-62706E023703}">
                       <ahyp:hlinkClr xmlns:ahyp="http://schemas.microsoft.com/office/drawing/2018/hyperlinkcolor" val="tx"/>
@@ -16732,7 +16732,7 @@
                   </a:extLst>
                 </a:hlinkClick>
               </a:rPr>
-              <a:t>Watch the clip, either side</a:t>
+              <a:t>Watch the clip, before and after</a:t>
             </a:r>
             <a:endParaRPr lang="en-US" sz="660" dirty="0"/>
           </a:p>
@@ -16823,7 +16823,7 @@
                 <a:latin typeface="Calibri" pitchFamily="34" charset="0"/>
                 <a:ea typeface="Calibri" pitchFamily="34" charset="-122"/>
                 <a:cs typeface="Calibri" pitchFamily="34" charset="-120"/>
-                <a:hlinkClick r:id="rId22" invalidUrl="" action="" tgtFrame="" tooltip="Why it was graded, and classified" history="1" highlightClick="0" endSnd="0">
+                <a:hlinkClick r:id="rId22" invalidUrl="" action="" tgtFrame="" tooltip="Why it was graded and classified" history="1" highlightClick="0" endSnd="0">
                   <a:extLst>
                     <a:ext uri="{A12FA001-AC4F-418D-AE19-62706E023703}">
                       <ahyp:hlinkClr xmlns:ahyp="http://schemas.microsoft.com/office/drawing/2018/hyperlinkcolor" val="tx"/>
@@ -16851,7 +16851,7 @@
                 <a:latin typeface="Calibri" pitchFamily="34" charset="0"/>
                 <a:ea typeface="Calibri" pitchFamily="34" charset="-122"/>
                 <a:cs typeface="Calibri" pitchFamily="34" charset="-120"/>
-                <a:hlinkClick r:id="rId23" invalidUrl="" action="" tgtFrame="" tooltip="Why it was graded, and classified" history="1" highlightClick="0" endSnd="0">
+                <a:hlinkClick r:id="rId23" invalidUrl="" action="" tgtFrame="" tooltip="Why it was graded and classified" history="1" highlightClick="0" endSnd="0">
                   <a:extLst>
                     <a:ext uri="{A12FA001-AC4F-418D-AE19-62706E023703}">
                       <ahyp:hlinkClr xmlns:ahyp="http://schemas.microsoft.com/office/drawing/2018/hyperlinkcolor" val="tx"/>
@@ -16859,7 +16859,7 @@
                   </a:extLst>
                 </a:hlinkClick>
               </a:rPr>
-              <a:t>Why it was graded, and classified</a:t>
+              <a:t>Why it was graded and classified</a:t>
             </a:r>
             <a:endParaRPr lang="en-US" sz="660" dirty="0"/>
           </a:p>
@@ -17204,7 +17204,7 @@
                 <a:latin typeface="Calibri" pitchFamily="34" charset="0"/>
                 <a:ea typeface="Calibri" pitchFamily="34" charset="-122"/>
                 <a:cs typeface="Calibri" pitchFamily="34" charset="-120"/>
-                <a:hlinkClick r:id="rId28" invalidUrl="" action="" tgtFrame="" tooltip="Log a coaching conversation" history="1" highlightClick="0" endSnd="0">
+                <a:hlinkClick r:id="rId28" invalidUrl="" action="" tgtFrame="" tooltip="Record a coaching conversation" history="1" highlightClick="0" endSnd="0">
                   <a:extLst>
                     <a:ext uri="{A12FA001-AC4F-418D-AE19-62706E023703}">
                       <ahyp:hlinkClr xmlns:ahyp="http://schemas.microsoft.com/office/drawing/2018/hyperlinkcolor" val="tx"/>
@@ -17232,7 +17232,7 @@
                 <a:latin typeface="Calibri" pitchFamily="34" charset="0"/>
                 <a:ea typeface="Calibri" pitchFamily="34" charset="-122"/>
                 <a:cs typeface="Calibri" pitchFamily="34" charset="-120"/>
-                <a:hlinkClick r:id="rId29" invalidUrl="" action="" tgtFrame="" tooltip="Log a coaching conversation" history="1" highlightClick="0" endSnd="0">
+                <a:hlinkClick r:id="rId29" invalidUrl="" action="" tgtFrame="" tooltip="Record a coaching conversation" history="1" highlightClick="0" endSnd="0">
                   <a:extLst>
                     <a:ext uri="{A12FA001-AC4F-418D-AE19-62706E023703}">
                       <ahyp:hlinkClr xmlns:ahyp="http://schemas.microsoft.com/office/drawing/2018/hyperlinkcolor" val="tx"/>
@@ -17240,7 +17240,7 @@
                   </a:extLst>
                 </a:hlinkClick>
               </a:rPr>
-              <a:t>Log a coaching conversation</a:t>
+              <a:t>Record a coaching conversation</a:t>
             </a:r>
             <a:endParaRPr lang="en-US" sz="660" dirty="0"/>
           </a:p>
@@ -17331,7 +17331,7 @@
                 <a:latin typeface="Calibri" pitchFamily="34" charset="0"/>
                 <a:ea typeface="Calibri" pitchFamily="34" charset="-122"/>
                 <a:cs typeface="Calibri" pitchFamily="34" charset="-120"/>
-                <a:hlinkClick r:id="rId30" invalidUrl="" action="" tgtFrame="" tooltip="Capture what the driver said" history="1" highlightClick="0" endSnd="0">
+                <a:hlinkClick r:id="rId30" invalidUrl="" action="" tgtFrame="" tooltip="Capture the driver’s own words" history="1" highlightClick="0" endSnd="0">
                   <a:extLst>
                     <a:ext uri="{A12FA001-AC4F-418D-AE19-62706E023703}">
                       <ahyp:hlinkClr xmlns:ahyp="http://schemas.microsoft.com/office/drawing/2018/hyperlinkcolor" val="tx"/>
@@ -17359,7 +17359,7 @@
                 <a:latin typeface="Calibri" pitchFamily="34" charset="0"/>
                 <a:ea typeface="Calibri" pitchFamily="34" charset="-122"/>
                 <a:cs typeface="Calibri" pitchFamily="34" charset="-120"/>
-                <a:hlinkClick r:id="rId31" invalidUrl="" action="" tgtFrame="" tooltip="Capture what the driver said" history="1" highlightClick="0" endSnd="0">
+                <a:hlinkClick r:id="rId31" invalidUrl="" action="" tgtFrame="" tooltip="Capture the driver’s own words" history="1" highlightClick="0" endSnd="0">
                   <a:extLst>
                     <a:ext uri="{A12FA001-AC4F-418D-AE19-62706E023703}">
                       <ahyp:hlinkClr xmlns:ahyp="http://schemas.microsoft.com/office/drawing/2018/hyperlinkcolor" val="tx"/>
@@ -17367,7 +17367,7 @@
                   </a:extLst>
                 </a:hlinkClick>
               </a:rPr>
-              <a:t>Capture what the driver said</a:t>
+              <a:t>Capture the driver’s own words</a:t>
             </a:r>
             <a:endParaRPr lang="en-US" sz="660" dirty="0"/>
           </a:p>
@@ -17458,7 +17458,7 @@
                 <a:latin typeface="Calibri" pitchFamily="34" charset="0"/>
                 <a:ea typeface="Calibri" pitchFamily="34" charset="-122"/>
                 <a:cs typeface="Calibri" pitchFamily="34" charset="-120"/>
-                <a:hlinkClick r:id="rId32" invalidUrl="" action="" tgtFrame="" tooltip="Confirm recognition" history="1" highlightClick="0" endSnd="0">
+                <a:hlinkClick r:id="rId32" invalidUrl="" action="" tgtFrame="" tooltip="Confirm a driver avoided harm" history="1" highlightClick="0" endSnd="0">
                   <a:extLst>
                     <a:ext uri="{A12FA001-AC4F-418D-AE19-62706E023703}">
                       <ahyp:hlinkClr xmlns:ahyp="http://schemas.microsoft.com/office/drawing/2018/hyperlinkcolor" val="tx"/>
@@ -17486,7 +17486,7 @@
                 <a:latin typeface="Calibri" pitchFamily="34" charset="0"/>
                 <a:ea typeface="Calibri" pitchFamily="34" charset="-122"/>
                 <a:cs typeface="Calibri" pitchFamily="34" charset="-120"/>
-                <a:hlinkClick r:id="rId33" invalidUrl="" action="" tgtFrame="" tooltip="Confirm recognition" history="1" highlightClick="0" endSnd="0">
+                <a:hlinkClick r:id="rId33" invalidUrl="" action="" tgtFrame="" tooltip="Confirm a driver avoided harm" history="1" highlightClick="0" endSnd="0">
                   <a:extLst>
                     <a:ext uri="{A12FA001-AC4F-418D-AE19-62706E023703}">
                       <ahyp:hlinkClr xmlns:ahyp="http://schemas.microsoft.com/office/drawing/2018/hyperlinkcolor" val="tx"/>
@@ -17494,7 +17494,7 @@
                   </a:extLst>
                 </a:hlinkClick>
               </a:rPr>
-              <a:t>Confirm recognition</a:t>
+              <a:t>Confirm a driver avoided harm</a:t>
             </a:r>
             <a:endParaRPr lang="en-US" sz="660" dirty="0"/>
           </a:p>
@@ -17712,7 +17712,7 @@
                 <a:latin typeface="Calibri" pitchFamily="34" charset="0"/>
                 <a:ea typeface="Calibri" pitchFamily="34" charset="-122"/>
                 <a:cs typeface="Calibri" pitchFamily="34" charset="-120"/>
-                <a:hlinkClick r:id="rId36" invalidUrl="" action="" tgtFrame="" tooltip="A driver record showing both sides" history="1" highlightClick="0" endSnd="0">
+                <a:hlinkClick r:id="rId36" invalidUrl="" action="" tgtFrame="" tooltip="A driver record, both sides" history="1" highlightClick="0" endSnd="0">
                   <a:extLst>
                     <a:ext uri="{A12FA001-AC4F-418D-AE19-62706E023703}">
                       <ahyp:hlinkClr xmlns:ahyp="http://schemas.microsoft.com/office/drawing/2018/hyperlinkcolor" val="tx"/>
@@ -17740,7 +17740,7 @@
                 <a:latin typeface="Calibri" pitchFamily="34" charset="0"/>
                 <a:ea typeface="Calibri" pitchFamily="34" charset="-122"/>
                 <a:cs typeface="Calibri" pitchFamily="34" charset="-120"/>
-                <a:hlinkClick r:id="rId37" invalidUrl="" action="" tgtFrame="" tooltip="A driver record showing both sides" history="1" highlightClick="0" endSnd="0">
+                <a:hlinkClick r:id="rId37" invalidUrl="" action="" tgtFrame="" tooltip="A driver record, both sides" history="1" highlightClick="0" endSnd="0">
                   <a:extLst>
                     <a:ext uri="{A12FA001-AC4F-418D-AE19-62706E023703}">
                       <ahyp:hlinkClr xmlns:ahyp="http://schemas.microsoft.com/office/drawing/2018/hyperlinkcolor" val="tx"/>
@@ -17748,7 +17748,7 @@
                   </a:extLst>
                 </a:hlinkClick>
               </a:rPr>
-              <a:t>A driver record showing both sides</a:t>
+              <a:t>A driver record, both sides</a:t>
             </a:r>
             <a:endParaRPr lang="en-US" sz="660" dirty="0"/>
           </a:p>
@@ -18160,7 +18160,7 @@
                 <a:latin typeface="Calibri" pitchFamily="34" charset="0"/>
                 <a:ea typeface="Calibri" pitchFamily="34" charset="-122"/>
                 <a:cs typeface="Calibri" pitchFamily="34" charset="-120"/>
-                <a:hlinkClick r:id="rId38" invalidUrl="" action="" tgtFrame="" tooltip="A fleet view that does not overstate" history="1" highlightClick="0" endSnd="0">
+                <a:hlinkClick r:id="rId38" invalidUrl="" action="" tgtFrame="" tooltip="A fleet view that admits its limits" history="1" highlightClick="0" endSnd="0">
                   <a:extLst>
                     <a:ext uri="{A12FA001-AC4F-418D-AE19-62706E023703}">
                       <ahyp:hlinkClr xmlns:ahyp="http://schemas.microsoft.com/office/drawing/2018/hyperlinkcolor" val="tx"/>
@@ -18188,7 +18188,7 @@
                 <a:latin typeface="Calibri" pitchFamily="34" charset="0"/>
                 <a:ea typeface="Calibri" pitchFamily="34" charset="-122"/>
                 <a:cs typeface="Calibri" pitchFamily="34" charset="-120"/>
-                <a:hlinkClick r:id="rId39" invalidUrl="" action="" tgtFrame="" tooltip="A fleet view that does not overstate" history="1" highlightClick="0" endSnd="0">
+                <a:hlinkClick r:id="rId39" invalidUrl="" action="" tgtFrame="" tooltip="A fleet view that admits its limits" history="1" highlightClick="0" endSnd="0">
                   <a:extLst>
                     <a:ext uri="{A12FA001-AC4F-418D-AE19-62706E023703}">
                       <ahyp:hlinkClr xmlns:ahyp="http://schemas.microsoft.com/office/drawing/2018/hyperlinkcolor" val="tx"/>
@@ -18196,7 +18196,7 @@
                   </a:extLst>
                 </a:hlinkClick>
               </a:rPr>
-              <a:t>A fleet view that does not overstate</a:t>
+              <a:t>A fleet view that admits its limits</a:t>
             </a:r>
             <a:endParaRPr lang="en-US" sz="660" dirty="0"/>
           </a:p>
@@ -18388,7 +18388,7 @@
                 <a:latin typeface="Calibri" pitchFamily="34" charset="0"/>
                 <a:ea typeface="Calibri" pitchFamily="34" charset="-122"/>
                 <a:cs typeface="Calibri" pitchFamily="34" charset="-120"/>
-                <a:hlinkClick r:id="rId40" invalidUrl="" action="" tgtFrame="" tooltip="Headway and fatigue" history="1" highlightClick="0" endSnd="0">
+                <a:hlinkClick r:id="rId40" invalidUrl="" action="" tgtFrame="" tooltip="Headway and fatigue wait" history="1" highlightClick="0" endSnd="0">
                   <a:extLst>
                     <a:ext uri="{A12FA001-AC4F-418D-AE19-62706E023703}">
                       <ahyp:hlinkClr xmlns:ahyp="http://schemas.microsoft.com/office/drawing/2018/hyperlinkcolor" val="tx"/>
@@ -18396,7 +18396,7 @@
                   </a:extLst>
                 </a:hlinkClick>
               </a:rPr>
-              <a:t>ADR-0012
+              <a:t>ADR-0001
 </a:t>
             </a:r>
             <a:endParaRPr lang="en-US" sz="660" dirty="0"/>
@@ -18416,7 +18416,7 @@
                 <a:latin typeface="Calibri" pitchFamily="34" charset="0"/>
                 <a:ea typeface="Calibri" pitchFamily="34" charset="-122"/>
                 <a:cs typeface="Calibri" pitchFamily="34" charset="-120"/>
-                <a:hlinkClick r:id="rId41" invalidUrl="" action="" tgtFrame="" tooltip="Headway and fatigue" history="1" highlightClick="0" endSnd="0">
+                <a:hlinkClick r:id="rId41" invalidUrl="" action="" tgtFrame="" tooltip="Headway and fatigue wait" history="1" highlightClick="0" endSnd="0">
                   <a:extLst>
                     <a:ext uri="{A12FA001-AC4F-418D-AE19-62706E023703}">
                       <ahyp:hlinkClr xmlns:ahyp="http://schemas.microsoft.com/office/drawing/2018/hyperlinkcolor" val="tx"/>
@@ -18424,7 +18424,7 @@
                   </a:extLst>
                 </a:hlinkClick>
               </a:rPr>
-              <a:t>Headway and fatigue</a:t>
+              <a:t>Headway and fatigue wait</a:t>
             </a:r>
             <a:endParaRPr lang="en-US" sz="660" dirty="0"/>
           </a:p>
@@ -18515,7 +18515,7 @@
                 <a:latin typeface="Calibri" pitchFamily="34" charset="0"/>
                 <a:ea typeface="Calibri" pitchFamily="34" charset="-122"/>
                 <a:cs typeface="Calibri" pitchFamily="34" charset="-120"/>
-                <a:hlinkClick r:id="rId42" invalidUrl="" action="" tgtFrame="" tooltip="Re-engagement on non-use" history="1" highlightClick="0" endSnd="0">
+                <a:hlinkClick r:id="rId42" invalidUrl="" action="" tgtFrame="" tooltip="What to do when nobody looks" history="1" highlightClick="0" endSnd="0">
                   <a:extLst>
                     <a:ext uri="{A12FA001-AC4F-418D-AE19-62706E023703}">
                       <ahyp:hlinkClr xmlns:ahyp="http://schemas.microsoft.com/office/drawing/2018/hyperlinkcolor" val="tx"/>
@@ -18543,7 +18543,7 @@
                 <a:latin typeface="Calibri" pitchFamily="34" charset="0"/>
                 <a:ea typeface="Calibri" pitchFamily="34" charset="-122"/>
                 <a:cs typeface="Calibri" pitchFamily="34" charset="-120"/>
-                <a:hlinkClick r:id="rId43" invalidUrl="" action="" tgtFrame="" tooltip="Re-engagement on non-use" history="1" highlightClick="0" endSnd="0">
+                <a:hlinkClick r:id="rId43" invalidUrl="" action="" tgtFrame="" tooltip="What to do when nobody looks" history="1" highlightClick="0" endSnd="0">
                   <a:extLst>
                     <a:ext uri="{A12FA001-AC4F-418D-AE19-62706E023703}">
                       <ahyp:hlinkClr xmlns:ahyp="http://schemas.microsoft.com/office/drawing/2018/hyperlinkcolor" val="tx"/>
@@ -18551,7 +18551,7 @@
                   </a:extLst>
                 </a:hlinkClick>
               </a:rPr>
-              <a:t>Re-engagement on non-use</a:t>
+              <a:t>What to do when nobody looks</a:t>
             </a:r>
             <a:endParaRPr lang="en-US" sz="660" dirty="0"/>
           </a:p>
@@ -18808,7 +18808,7 @@
                 <a:latin typeface="Calibri" pitchFamily="34" charset="0"/>
                 <a:ea typeface="Calibri" pitchFamily="34" charset="-122"/>
                 <a:cs typeface="Calibri" pitchFamily="34" charset="-120"/>
-                <a:hlinkClick r:id="rId46" invalidUrl="" action="" tgtFrame="" tooltip="Any driver-facing surface" history="1" highlightClick="0" endSnd="0">
+                <a:hlinkClick r:id="rId46" invalidUrl="" action="" tgtFrame="" tooltip="Anything the driver sees directly" history="1" highlightClick="0" endSnd="0">
                   <a:extLst>
                     <a:ext uri="{A12FA001-AC4F-418D-AE19-62706E023703}">
                       <ahyp:hlinkClr xmlns:ahyp="http://schemas.microsoft.com/office/drawing/2018/hyperlinkcolor" val="tx"/>
@@ -18836,7 +18836,7 @@
                 <a:latin typeface="Calibri" pitchFamily="34" charset="0"/>
                 <a:ea typeface="Calibri" pitchFamily="34" charset="-122"/>
                 <a:cs typeface="Calibri" pitchFamily="34" charset="-120"/>
-                <a:hlinkClick r:id="rId47" invalidUrl="" action="" tgtFrame="" tooltip="Any driver-facing surface" history="1" highlightClick="0" endSnd="0">
+                <a:hlinkClick r:id="rId47" invalidUrl="" action="" tgtFrame="" tooltip="Anything the driver sees directly" history="1" highlightClick="0" endSnd="0">
                   <a:extLst>
                     <a:ext uri="{A12FA001-AC4F-418D-AE19-62706E023703}">
                       <ahyp:hlinkClr xmlns:ahyp="http://schemas.microsoft.com/office/drawing/2018/hyperlinkcolor" val="tx"/>
@@ -18844,7 +18844,7 @@
                   </a:extLst>
                 </a:hlinkClick>
               </a:rPr>
-              <a:t>Any driver-facing surface</a:t>
+              <a:t>Anything the driver sees directly</a:t>
             </a:r>
             <a:endParaRPr lang="en-US" sz="660" dirty="0"/>
           </a:p>
@@ -18935,7 +18935,7 @@
                 <a:latin typeface="Calibri" pitchFamily="34" charset="0"/>
                 <a:ea typeface="Calibri" pitchFamily="34" charset="-122"/>
                 <a:cs typeface="Calibri" pitchFamily="34" charset="-120"/>
-                <a:hlinkClick r:id="rId48" invalidUrl="" action="" tgtFrame="" tooltip="Depot-manager handover" history="1" highlightClick="0" endSnd="0">
+                <a:hlinkClick r:id="rId48" invalidUrl="" action="" tgtFrame="" tooltip="Handover to a depot manager" history="1" highlightClick="0" endSnd="0">
                   <a:extLst>
                     <a:ext uri="{A12FA001-AC4F-418D-AE19-62706E023703}">
                       <ahyp:hlinkClr xmlns:ahyp="http://schemas.microsoft.com/office/drawing/2018/hyperlinkcolor" val="tx"/>
@@ -18963,7 +18963,7 @@
                 <a:latin typeface="Calibri" pitchFamily="34" charset="0"/>
                 <a:ea typeface="Calibri" pitchFamily="34" charset="-122"/>
                 <a:cs typeface="Calibri" pitchFamily="34" charset="-120"/>
-                <a:hlinkClick r:id="rId49" invalidUrl="" action="" tgtFrame="" tooltip="Depot-manager handover" history="1" highlightClick="0" endSnd="0">
+                <a:hlinkClick r:id="rId49" invalidUrl="" action="" tgtFrame="" tooltip="Handover to a depot manager" history="1" highlightClick="0" endSnd="0">
                   <a:extLst>
                     <a:ext uri="{A12FA001-AC4F-418D-AE19-62706E023703}">
                       <ahyp:hlinkClr xmlns:ahyp="http://schemas.microsoft.com/office/drawing/2018/hyperlinkcolor" val="tx"/>
@@ -18971,7 +18971,7 @@
                   </a:extLst>
                 </a:hlinkClick>
               </a:rPr>
-              <a:t>Depot-manager handover</a:t>
+              <a:t>Handover to a depot manager</a:t>
             </a:r>
             <a:endParaRPr lang="en-US" sz="660" dirty="0"/>
           </a:p>

</xml_diff>